<commit_message>
Auto commit on change detected at dim.  1 juin 2025 20:14:15
</commit_message>
<xml_diff>
--- a/IRT2/Q2/Math info/Math_S6.pptx
+++ b/IRT2/Q2/Math info/Math_S6.pptx
@@ -235,7 +235,7 @@
           <a:p>
             <a:fld id="{DB8D3EB8-6AD6-4DF3-B16B-A9E0B517D683}" type="datetimeFigureOut">
               <a:rPr lang="fr-BE" smtClean="0"/>
-              <a:t>27-05-25</a:t>
+              <a:t>29-05-25</a:t>
             </a:fld>
             <a:endParaRPr lang="fr-BE"/>
           </a:p>
@@ -400,7 +400,7 @@
           <a:p>
             <a:fld id="{11702AF6-C27A-47C0-BCF6-EC35CFE95046}" type="datetimeFigureOut">
               <a:rPr lang="fr-BE" smtClean="0"/>
-              <a:t>27-05-25</a:t>
+              <a:t>28-05-25</a:t>
             </a:fld>
             <a:endParaRPr lang="fr-BE"/>
           </a:p>
@@ -7119,7 +7119,7 @@
           <a:p>
             <a:r>
               <a:rPr lang="fr-FR" dirty="0"/>
-              <a:t>Code de Turing v1.0</a:t>
+              <a:t>Code de Turing v1.0 </a:t>
             </a:r>
             <a:endParaRPr lang="fr-BE" dirty="0"/>
           </a:p>

</xml_diff>